<commit_message>
Add post-turn source incident capture
</commit_message>
<xml_diff>
--- a/outputs/manual-20260510-2148-aiwiki-ppt/presentations/ai-wiki-toolkit-showcase/output/ai-wiki-toolkit-project-showcase v2.pptx
+++ b/outputs/manual-20260510-2148-aiwiki-ppt/presentations/ai-wiki-toolkit-showcase/output/ai-wiki-toolkit-project-showcase v2.pptx
@@ -5086,6 +5086,185 @@
           </a:p>
         </p:txBody>
       </p:sp>
+      <p:sp>
+        <p:nvSpPr>
+          <p:cNvPr id="6" name="Rectangle 5">
+            <a:extLst>
+              <a:ext uri="{FF2B5EF4-FFF2-40B4-BE49-F238E27FC236}">
+                <a16:creationId xmlns:a16="http://schemas.microsoft.com/office/drawing/2014/main" id="{EBB54649-C47C-2623-F470-827579797480}"/>
+              </a:ext>
+            </a:extLst>
+          </p:cNvPr>
+          <p:cNvSpPr>
+            <a:spLocks noGrp="1"/>
+          </p:cNvSpPr>
+          <p:nvPr/>
+        </p:nvSpPr>
+        <p:spPr>
+          <a:xfrm>
+            <a:off x="552450" y="2152650"/>
+            <a:ext cx="5429250" cy="1701358"/>
+          </a:xfrm>
+          <a:prstGeom prst="rect">
+            <a:avLst/>
+          </a:prstGeom>
+          <a:solidFill>
+            <a:srgbClr val="000000">
+              <a:alpha val="0"/>
+            </a:srgbClr>
+          </a:solidFill>
+          <a:ln w="0">
+            <a:solidFill>
+              <a:srgbClr val="000000">
+                <a:alpha val="0"/>
+              </a:srgbClr>
+            </a:solidFill>
+            <a:prstDash val="solid"/>
+          </a:ln>
+        </p:spPr>
+        <p:txBody>
+          <a:bodyPr lIns="0" tIns="0" rIns="0" bIns="0" anchor="t"/>
+          <a:lstStyle/>
+          <a:p>
+            <a:pPr>
+              <a:defRPr sz="1200" b="0">
+                <a:solidFill>
+                  <a:srgbClr val="B8C5C8"/>
+                </a:solidFill>
+                <a:latin typeface="Aptos"/>
+                <a:ea typeface="Aptos"/>
+                <a:cs typeface="Aptos"/>
+              </a:defRPr>
+            </a:pPr>
+            <a:r>
+              <a:rPr lang="en-AU" sz="1600" b="1" dirty="0">
+                <a:solidFill>
+                  <a:srgbClr val="172126"/>
+                </a:solidFill>
+                <a:latin typeface="Aptos Display"/>
+              </a:rPr>
+              <a:t>Install it</a:t>
+            </a:r>
+          </a:p>
+          <a:p>
+            <a:pPr>
+              <a:defRPr sz="1200" b="0">
+                <a:solidFill>
+                  <a:srgbClr val="B8C5C8"/>
+                </a:solidFill>
+                <a:latin typeface="Aptos"/>
+                <a:ea typeface="Aptos"/>
+                <a:cs typeface="Aptos"/>
+              </a:defRPr>
+            </a:pPr>
+            <a:r>
+              <a:rPr lang="en-AU" sz="1600" b="1" dirty="0">
+                <a:solidFill>
+                  <a:srgbClr val="172126"/>
+                </a:solidFill>
+                <a:latin typeface="Aptos Display"/>
+              </a:rPr>
+              <a:t> - </a:t>
+            </a:r>
+            <a:r>
+              <a:rPr lang="en-AU" sz="1600" b="1" dirty="0" err="1">
+                <a:solidFill>
+                  <a:srgbClr val="172126"/>
+                </a:solidFill>
+                <a:latin typeface="Aptos Display"/>
+              </a:rPr>
+              <a:t>npm</a:t>
+            </a:r>
+            <a:r>
+              <a:rPr lang="en-AU" sz="1600" b="1" dirty="0">
+                <a:solidFill>
+                  <a:srgbClr val="172126"/>
+                </a:solidFill>
+                <a:latin typeface="Aptos Display"/>
+              </a:rPr>
+              <a:t> install -g ai-wiki-toolkit</a:t>
+            </a:r>
+          </a:p>
+          <a:p>
+            <a:pPr>
+              <a:defRPr sz="1200" b="0">
+                <a:solidFill>
+                  <a:srgbClr val="B8C5C8"/>
+                </a:solidFill>
+                <a:latin typeface="Aptos"/>
+                <a:ea typeface="Aptos"/>
+                <a:cs typeface="Aptos"/>
+              </a:defRPr>
+            </a:pPr>
+            <a:endParaRPr lang="en-AU" sz="1600" b="1" dirty="0">
+              <a:solidFill>
+                <a:srgbClr val="172126"/>
+              </a:solidFill>
+              <a:latin typeface="Aptos Display"/>
+            </a:endParaRPr>
+          </a:p>
+          <a:p>
+            <a:pPr>
+              <a:defRPr sz="1200" b="0">
+                <a:solidFill>
+                  <a:srgbClr val="B8C5C8"/>
+                </a:solidFill>
+                <a:latin typeface="Aptos"/>
+                <a:ea typeface="Aptos"/>
+                <a:cs typeface="Aptos"/>
+              </a:defRPr>
+            </a:pPr>
+            <a:r>
+              <a:rPr lang="en-AU" sz="1600" b="1" dirty="0">
+                <a:solidFill>
+                  <a:srgbClr val="172126"/>
+                </a:solidFill>
+                <a:latin typeface="Aptos Display"/>
+              </a:rPr>
+              <a:t>Enter your target repo, then run</a:t>
+            </a:r>
+          </a:p>
+          <a:p>
+            <a:pPr>
+              <a:defRPr sz="1200" b="0">
+                <a:solidFill>
+                  <a:srgbClr val="B8C5C8"/>
+                </a:solidFill>
+                <a:latin typeface="Aptos"/>
+                <a:ea typeface="Aptos"/>
+                <a:cs typeface="Aptos"/>
+              </a:defRPr>
+            </a:pPr>
+            <a:r>
+              <a:rPr lang="en-AU" sz="1600" b="1" dirty="0">
+                <a:solidFill>
+                  <a:srgbClr val="172126"/>
+                </a:solidFill>
+                <a:latin typeface="Aptos Display"/>
+              </a:rPr>
+              <a:t> - </a:t>
+            </a:r>
+            <a:r>
+              <a:rPr lang="en-AU" sz="1600" b="1" dirty="0" err="1">
+                <a:solidFill>
+                  <a:srgbClr val="172126"/>
+                </a:solidFill>
+                <a:latin typeface="Aptos Display"/>
+              </a:rPr>
+              <a:t>aiwiki</a:t>
+            </a:r>
+            <a:r>
+              <a:rPr lang="en-AU" sz="1600" b="1" dirty="0">
+                <a:solidFill>
+                  <a:srgbClr val="172126"/>
+                </a:solidFill>
+                <a:latin typeface="Aptos Display"/>
+              </a:rPr>
+              <a:t>-toolkit install</a:t>
+            </a:r>
+          </a:p>
+        </p:txBody>
+      </p:sp>
     </p:spTree>
     <p:extLst>
       <p:ext uri="{BB962C8B-B14F-4D97-AF65-F5344CB8AC3E}">
@@ -5389,140 +5568,6 @@
       </p:sp>
       <p:sp>
         <p:nvSpPr>
-          <p:cNvPr id="6" name="Rectangle 5">
-            <a:extLst>
-              <a:ext uri="{FF2B5EF4-FFF2-40B4-BE49-F238E27FC236}">
-                <a16:creationId xmlns:a16="http://schemas.microsoft.com/office/drawing/2014/main" id="{3FEA4242-582D-4239-90F1-DA78FBCC09D1}"/>
-              </a:ext>
-            </a:extLst>
-          </p:cNvPr>
-          <p:cNvSpPr>
-            <a:spLocks noGrp="1"/>
-          </p:cNvSpPr>
-          <p:nvPr/>
-        </p:nvSpPr>
-        <p:spPr>
-          <a:xfrm>
-            <a:off x="590550" y="3257550"/>
-            <a:ext cx="5429250" cy="1009650"/>
-          </a:xfrm>
-          <a:prstGeom prst="rect">
-            <a:avLst/>
-          </a:prstGeom>
-          <a:solidFill>
-            <a:srgbClr val="000000">
-              <a:alpha val="0"/>
-            </a:srgbClr>
-          </a:solidFill>
-          <a:ln w="0">
-            <a:solidFill>
-              <a:srgbClr val="000000">
-                <a:alpha val="0"/>
-              </a:srgbClr>
-            </a:solidFill>
-            <a:prstDash val="solid"/>
-          </a:ln>
-        </p:spPr>
-        <p:txBody>
-          <a:bodyPr lIns="0" tIns="0" rIns="0" bIns="0" anchor="t"/>
-          <a:lstStyle/>
-          <a:p>
-            <a:pPr>
-              <a:defRPr sz="1200" b="0">
-                <a:solidFill>
-                  <a:srgbClr val="B8C5C8"/>
-                </a:solidFill>
-                <a:latin typeface="Aptos"/>
-                <a:ea typeface="Aptos"/>
-                <a:cs typeface="Aptos"/>
-              </a:defRPr>
-            </a:pPr>
-            <a:r>
-              <a:rPr lang="en-AU" sz="1200" dirty="0"/>
-              <a:t>Install it</a:t>
-            </a:r>
-          </a:p>
-          <a:p>
-            <a:pPr>
-              <a:defRPr sz="1200" b="0">
-                <a:solidFill>
-                  <a:srgbClr val="B8C5C8"/>
-                </a:solidFill>
-                <a:latin typeface="Aptos"/>
-                <a:ea typeface="Aptos"/>
-                <a:cs typeface="Aptos"/>
-              </a:defRPr>
-            </a:pPr>
-            <a:r>
-              <a:rPr lang="en-AU" sz="1200" dirty="0"/>
-              <a:t> - </a:t>
-            </a:r>
-            <a:r>
-              <a:rPr lang="en-AU" sz="1200" dirty="0" err="1"/>
-              <a:t>npm</a:t>
-            </a:r>
-            <a:r>
-              <a:rPr lang="en-AU" sz="1200" dirty="0"/>
-              <a:t> install -g ai-wiki-toolkit</a:t>
-            </a:r>
-          </a:p>
-          <a:p>
-            <a:pPr>
-              <a:defRPr sz="1200" b="0">
-                <a:solidFill>
-                  <a:srgbClr val="B8C5C8"/>
-                </a:solidFill>
-                <a:latin typeface="Aptos"/>
-                <a:ea typeface="Aptos"/>
-                <a:cs typeface="Aptos"/>
-              </a:defRPr>
-            </a:pPr>
-            <a:endParaRPr lang="en-AU" sz="1200" dirty="0"/>
-          </a:p>
-          <a:p>
-            <a:pPr>
-              <a:defRPr sz="1200" b="0">
-                <a:solidFill>
-                  <a:srgbClr val="B8C5C8"/>
-                </a:solidFill>
-                <a:latin typeface="Aptos"/>
-                <a:ea typeface="Aptos"/>
-                <a:cs typeface="Aptos"/>
-              </a:defRPr>
-            </a:pPr>
-            <a:r>
-              <a:rPr lang="en-AU" sz="1200" dirty="0"/>
-              <a:t>Enter your target repo</a:t>
-            </a:r>
-          </a:p>
-          <a:p>
-            <a:pPr>
-              <a:defRPr sz="1200" b="0">
-                <a:solidFill>
-                  <a:srgbClr val="B8C5C8"/>
-                </a:solidFill>
-                <a:latin typeface="Aptos"/>
-                <a:ea typeface="Aptos"/>
-                <a:cs typeface="Aptos"/>
-              </a:defRPr>
-            </a:pPr>
-            <a:r>
-              <a:rPr lang="en-AU" sz="1200" dirty="0"/>
-              <a:t> - </a:t>
-            </a:r>
-            <a:r>
-              <a:rPr lang="en-AU" sz="1200" dirty="0" err="1"/>
-              <a:t>aiwiki</a:t>
-            </a:r>
-            <a:r>
-              <a:rPr lang="en-AU" sz="1200" dirty="0"/>
-              <a:t>-toolkit install</a:t>
-            </a:r>
-          </a:p>
-        </p:txBody>
-      </p:sp>
-      <p:sp>
-        <p:nvSpPr>
           <p:cNvPr id="7" name="Rectangle 6">
             <a:extLst>
               <a:ext uri="{FF2B5EF4-FFF2-40B4-BE49-F238E27FC236}">
@@ -7002,7 +7047,51 @@
                 <a:ea typeface="Aptos Display"/>
                 <a:cs typeface="Aptos Display"/>
               </a:rPr>
-              <a:t>Agent work slows down because useful project knowledge decays between tasks.</a:t>
+              <a:t>Agent work </a:t>
+            </a:r>
+            <a:r>
+              <a:rPr lang="en-AU" sz="2625" b="1" dirty="0">
+                <a:solidFill>
+                  <a:srgbClr val="172126"/>
+                </a:solidFill>
+                <a:latin typeface="Aptos Display"/>
+                <a:ea typeface="Aptos Display"/>
+                <a:cs typeface="Aptos Display"/>
+              </a:rPr>
+              <a:t>repeats trial and error</a:t>
+            </a:r>
+            <a:r>
+              <a:rPr sz="2625" b="1" dirty="0">
+                <a:solidFill>
+                  <a:srgbClr val="172126"/>
+                </a:solidFill>
+                <a:latin typeface="Aptos Display"/>
+                <a:ea typeface="Aptos Display"/>
+                <a:cs typeface="Aptos Display"/>
+              </a:rPr>
+              <a:t> because useful project knowledge </a:t>
+            </a:r>
+            <a:r>
+              <a:rPr lang="en-AU" sz="2625" b="1" dirty="0">
+                <a:solidFill>
+                  <a:srgbClr val="172126"/>
+                </a:solidFill>
+                <a:latin typeface="Aptos Display"/>
+                <a:ea typeface="Aptos Display"/>
+                <a:cs typeface="Aptos Display"/>
+              </a:rPr>
+              <a:t>disappear</a:t>
+            </a:r>
+            <a:r>
+              <a:rPr sz="2625" b="1" dirty="0">
+                <a:solidFill>
+                  <a:srgbClr val="172126"/>
+                </a:solidFill>
+                <a:latin typeface="Aptos Display"/>
+                <a:ea typeface="Aptos Display"/>
+                <a:cs typeface="Aptos Display"/>
+              </a:rPr>
+              <a:t> between tasks.</a:t>
             </a:r>
             <a:r>
               <a:rPr lang="en-AU" sz="2625" b="1" dirty="0">
@@ -8328,8 +8417,8 @@
         </p:nvSpPr>
         <p:spPr>
           <a:xfrm>
-            <a:off x="2981325" y="2381250"/>
-            <a:ext cx="1066800" cy="228600"/>
+            <a:off x="2981324" y="2381250"/>
+            <a:ext cx="1190625" cy="228600"/>
           </a:xfrm>
           <a:prstGeom prst="rect">
             <a:avLst/>
@@ -8363,7 +8452,7 @@
               </a:defRPr>
             </a:pPr>
             <a:r>
-              <a:rPr sz="1050" b="1" dirty="0">
+              <a:rPr lang="en-AU" sz="1050" b="1" dirty="0">
                 <a:solidFill>
                   <a:srgbClr val="172126"/>
                 </a:solidFill>
@@ -8371,97 +8460,11 @@
                 <a:ea typeface="Aptos"/>
                 <a:cs typeface="Aptos"/>
               </a:rPr>
-              <a:t>Ad hoc RAG</a:t>
-            </a:r>
-          </a:p>
-        </p:txBody>
-      </p:sp>
-      <p:sp>
-        <p:nvSpPr>
-          <p:cNvPr id="32" name="Rectangle 31">
-            <a:extLst>
-              <a:ext uri="{FF2B5EF4-FFF2-40B4-BE49-F238E27FC236}">
-                <a16:creationId xmlns:a16="http://schemas.microsoft.com/office/drawing/2014/main" id="{E234F3E6-59DD-4C0D-BDA4-91405ED80C60}"/>
-              </a:ext>
-            </a:extLst>
-          </p:cNvPr>
-          <p:cNvSpPr>
-            <a:spLocks noGrp="1"/>
-          </p:cNvSpPr>
-          <p:nvPr/>
-        </p:nvSpPr>
-        <p:spPr>
-          <a:xfrm>
-            <a:off x="2981325" y="2619375"/>
-            <a:ext cx="1066800" cy="228600"/>
-          </a:xfrm>
-          <a:prstGeom prst="rect">
-            <a:avLst/>
-          </a:prstGeom>
-          <a:solidFill>
-            <a:srgbClr val="000000">
-              <a:alpha val="0"/>
-            </a:srgbClr>
-          </a:solidFill>
-          <a:ln w="0">
-            <a:solidFill>
-              <a:srgbClr val="000000">
-                <a:alpha val="0"/>
-              </a:srgbClr>
-            </a:solidFill>
-            <a:prstDash val="solid"/>
-          </a:ln>
-        </p:spPr>
-        <p:txBody>
-          <a:bodyPr lIns="0" tIns="0" rIns="0" bIns="0" anchor="t"/>
-          <a:lstStyle/>
-          <a:p>
-            <a:pPr algn="l">
-              <a:defRPr sz="713" b="0">
-                <a:solidFill>
-                  <a:srgbClr val="66706F"/>
-                </a:solidFill>
-                <a:latin typeface="Aptos"/>
-                <a:ea typeface="Aptos"/>
-                <a:cs typeface="Aptos"/>
-              </a:defRPr>
-            </a:pPr>
-            <a:r>
-              <a:rPr sz="713" b="0" dirty="0">
-                <a:solidFill>
-                  <a:srgbClr val="66706F"/>
-                </a:solidFill>
-                <a:latin typeface="Aptos"/>
-                <a:ea typeface="Aptos"/>
-                <a:cs typeface="Aptos"/>
-              </a:rPr>
-              <a:t>answers without </a:t>
-            </a:r>
-            <a:r>
-              <a:rPr lang="en-AU" sz="713" b="0" dirty="0">
-                <a:solidFill>
-                  <a:srgbClr val="66706F"/>
-                </a:solidFill>
-                <a:latin typeface="Aptos"/>
-                <a:ea typeface="Aptos"/>
-                <a:cs typeface="Aptos"/>
-              </a:rPr>
-              <a:t>u</a:t>
-            </a:r>
-            <a:r>
-              <a:rPr sz="713" b="0" dirty="0" err="1">
-                <a:solidFill>
-                  <a:srgbClr val="66706F"/>
-                </a:solidFill>
-                <a:latin typeface="Aptos"/>
-                <a:ea typeface="Aptos"/>
-                <a:cs typeface="Aptos"/>
-              </a:rPr>
-              <a:t>pkeep</a:t>
-            </a:r>
-            <a:endParaRPr sz="713" b="0" dirty="0">
+              <a:t>Coding Preference</a:t>
+            </a:r>
+            <a:endParaRPr sz="1050" b="1" dirty="0">
               <a:solidFill>
-                <a:srgbClr val="66706F"/>
+                <a:srgbClr val="172126"/>
               </a:solidFill>
               <a:latin typeface="Aptos"/>
               <a:ea typeface="Aptos"/>

</xml_diff>